<commit_message>
t_deckv3-links docs: team leader, full product link, no video placeholder
Slide 1: team leader name is Florentiana Yuwono.

Slide 16: the demo-video row is gone. The final product link is now the full
dashboard URL with apiBase, projectId, synthetic=1 and dest=fleet, split across
two lines so it stays readable at 8 pt, with both lines carrying the hyperlink.

The demo token is printed on the slide rather than appended to the URL: the
dashboard refuses a ?token= parameter by design (dashboard/config.js, task
t_5649d117) and scrubs it from the address bar, so a tokenised link would drop
the viewer at the sign-in prompt with the credential stripped.
</commit_message>
<xml_diff>
--- a/deck/v3/termini-deck-v3.pptx
+++ b/deck/v3/termini-deck-v3.pptx
@@ -5581,7 +5581,7 @@
                 </a:solidFill>
                 <a:latin typeface="Arial"/>
               </a:rPr>
-              <a:t>[to be filled]</a:t>
+              <a:t>Florentiana Yuwono</a:t>
             </a:r>
           </a:p>
           <a:p>
@@ -9720,8 +9720,8 @@
         </p:nvSpPr>
         <p:spPr>
           <a:xfrm>
-            <a:off x="265176" y="1828800"/>
-            <a:ext cx="3108960" cy="274320"/>
+            <a:off x="265176" y="1783080"/>
+            <a:ext cx="2377440" cy="274320"/>
           </a:xfrm>
           <a:prstGeom prst="rect">
             <a:avLst/>
@@ -9759,8 +9759,8 @@
         </p:nvSpPr>
         <p:spPr>
           <a:xfrm>
-            <a:off x="3474720" y="1828800"/>
-            <a:ext cx="5394960" cy="274320"/>
+            <a:off x="2697480" y="1783080"/>
+            <a:ext cx="6126480" cy="274320"/>
           </a:xfrm>
           <a:prstGeom prst="rect">
             <a:avLst/>
@@ -9799,8 +9799,8 @@
         </p:nvSpPr>
         <p:spPr>
           <a:xfrm>
-            <a:off x="265176" y="2487168"/>
-            <a:ext cx="3108960" cy="274320"/>
+            <a:off x="265176" y="2286000"/>
+            <a:ext cx="2377440" cy="274320"/>
           </a:xfrm>
           <a:prstGeom prst="rect">
             <a:avLst/>
@@ -9825,7 +9825,7 @@
                 </a:solidFill>
                 <a:latin typeface="Arial"/>
               </a:rPr>
-              <a:t>Demo video (3 minutes)</a:t>
+              <a:t>Final product link</a:t>
             </a:r>
           </a:p>
         </p:txBody>
@@ -9838,8 +9838,8 @@
         </p:nvSpPr>
         <p:spPr>
           <a:xfrm>
-            <a:off x="3474720" y="2487168"/>
-            <a:ext cx="5394960" cy="274320"/>
+            <a:off x="265176" y="2578608"/>
+            <a:ext cx="8613648" cy="228600"/>
           </a:xfrm>
           <a:prstGeom prst="rect">
             <a:avLst/>
@@ -9858,13 +9858,13 @@
               </a:lnSpc>
             </a:pPr>
             <a:r>
-              <a:rPr sz="1000" b="0">
-                <a:solidFill>
-                  <a:srgbClr val="B06000"/>
-                </a:solidFill>
-                <a:latin typeface="Arial"/>
-              </a:rPr>
-              <a:t>script ready; recording is the pending human step (SUBMISSION.md §5)</a:t>
+              <a:rPr sz="800" b="0">
+                <a:solidFill>
+                  <a:srgbClr val="5F6368"/>
+                </a:solidFill>
+                <a:latin typeface="Arial"/>
+              </a:rPr>
+              <a:t>opens the full dashboard: fleet, operator log, agents panel, synthetic nodes included</a:t>
             </a:r>
           </a:p>
         </p:txBody>
@@ -9877,8 +9877,65 @@
         </p:nvSpPr>
         <p:spPr>
           <a:xfrm>
-            <a:off x="265176" y="3145536"/>
-            <a:ext cx="3108960" cy="274320"/>
+            <a:off x="2697480" y="2852928"/>
+            <a:ext cx="6126480" cy="502920"/>
+          </a:xfrm>
+          <a:prstGeom prst="rect">
+            <a:avLst/>
+          </a:prstGeom>
+          <a:noFill/>
+        </p:spPr>
+        <p:txBody>
+          <a:bodyPr wrap="square" lIns="0" rIns="0" tIns="0" bIns="0" anchor="t">
+            <a:spAutoFit/>
+          </a:bodyPr>
+          <a:lstStyle/>
+          <a:p>
+            <a:pPr algn="l">
+              <a:lnSpc>
+                <a:spcPct val="135000"/>
+              </a:lnSpc>
+            </a:pPr>
+            <a:r>
+              <a:rPr sz="800" b="0">
+                <a:solidFill>
+                  <a:srgbClr val="1A73E8"/>
+                </a:solidFill>
+                <a:latin typeface="Arial"/>
+                <a:hlinkClick r:id="rId4"/>
+              </a:rPr>
+              <a:t>https://termini-510609.web.app/?apiBase=https%3A%2F%2F34-93-190-64.sslip.io%2Fv1</a:t>
+            </a:r>
+          </a:p>
+          <a:p>
+            <a:pPr algn="l">
+              <a:lnSpc>
+                <a:spcPct val="135000"/>
+              </a:lnSpc>
+            </a:pPr>
+            <a:r>
+              <a:rPr sz="800" b="0">
+                <a:solidFill>
+                  <a:srgbClr val="1A73E8"/>
+                </a:solidFill>
+                <a:latin typeface="Arial"/>
+                <a:hlinkClick r:id="rId4"/>
+              </a:rPr>
+              <a:t>&amp;projectId=01J0DEM0WARM000000000000AB&amp;synthetic=1&amp;dest=fleet</a:t>
+            </a:r>
+          </a:p>
+        </p:txBody>
+      </p:sp>
+      <p:sp>
+        <p:nvSpPr>
+          <p:cNvPr id="12" name="TextBox 11"/>
+          <p:cNvSpPr txBox="1"/>
+          <p:nvPr/>
+        </p:nvSpPr>
+        <p:spPr>
+          <a:xfrm>
+            <a:off x="265176" y="3611880"/>
+            <a:ext cx="2377440" cy="274320"/>
           </a:xfrm>
           <a:prstGeom prst="rect">
             <a:avLst/>
@@ -9903,21 +9960,21 @@
                 </a:solidFill>
                 <a:latin typeface="Arial"/>
               </a:rPr>
-              <a:t>Final product link</a:t>
-            </a:r>
-          </a:p>
-        </p:txBody>
-      </p:sp>
-      <p:sp>
-        <p:nvSpPr>
-          <p:cNvPr id="12" name="TextBox 11"/>
+              <a:t>Demo sign-in</a:t>
+            </a:r>
+          </a:p>
+        </p:txBody>
+      </p:sp>
+      <p:sp>
+        <p:nvSpPr>
+          <p:cNvPr id="13" name="TextBox 12"/>
           <p:cNvSpPr txBox="1"/>
           <p:nvPr/>
         </p:nvSpPr>
         <p:spPr>
           <a:xfrm>
-            <a:off x="3474720" y="3145536"/>
-            <a:ext cx="5394960" cy="274320"/>
+            <a:off x="2697480" y="3611880"/>
+            <a:ext cx="6126480" cy="274320"/>
           </a:xfrm>
           <a:prstGeom prst="rect">
             <a:avLst/>
@@ -9938,26 +9995,25 @@
             <a:r>
               <a:rPr sz="1000" b="0">
                 <a:solidFill>
-                  <a:srgbClr val="1A73E8"/>
-                </a:solidFill>
-                <a:latin typeface="Arial"/>
-                <a:hlinkClick r:id="rId4"/>
-              </a:rPr>
-              <a:t>termini-510609.web.app</a:t>
-            </a:r>
-          </a:p>
-        </p:txBody>
-      </p:sp>
-      <p:sp>
-        <p:nvSpPr>
-          <p:cNvPr id="13" name="TextBox 12"/>
+                  <a:srgbClr val="202124"/>
+                </a:solidFill>
+                <a:latin typeface="Arial"/>
+              </a:rPr>
+              <a:t>project token: demo-project-token</a:t>
+            </a:r>
+          </a:p>
+        </p:txBody>
+      </p:sp>
+      <p:sp>
+        <p:nvSpPr>
+          <p:cNvPr id="14" name="TextBox 13"/>
           <p:cNvSpPr txBox="1"/>
           <p:nvPr/>
         </p:nvSpPr>
         <p:spPr>
           <a:xfrm>
-            <a:off x="265176" y="3803904"/>
-            <a:ext cx="3108960" cy="274320"/>
+            <a:off x="2697480" y="3877056"/>
+            <a:ext cx="6126480" cy="274320"/>
           </a:xfrm>
           <a:prstGeom prst="rect">
             <a:avLst/>
@@ -9976,27 +10032,27 @@
               </a:lnSpc>
             </a:pPr>
             <a:r>
-              <a:rPr sz="1050" b="1">
-                <a:solidFill>
-                  <a:srgbClr val="202124"/>
-                </a:solidFill>
-                <a:latin typeface="Arial"/>
-              </a:rPr>
-              <a:t>Live API</a:t>
-            </a:r>
-          </a:p>
-        </p:txBody>
-      </p:sp>
-      <p:sp>
-        <p:nvSpPr>
-          <p:cNvPr id="14" name="TextBox 13"/>
+              <a:rPr sz="800" b="0">
+                <a:solidFill>
+                  <a:srgbClr val="5F6368"/>
+                </a:solidFill>
+                <a:latin typeface="Arial"/>
+              </a:rPr>
+              <a:t>the dashboard refuses a token inside a URL, so the token is printed here; paste it at Settings, then sign in</a:t>
+            </a:r>
+          </a:p>
+        </p:txBody>
+      </p:sp>
+      <p:sp>
+        <p:nvSpPr>
+          <p:cNvPr id="15" name="TextBox 14"/>
           <p:cNvSpPr txBox="1"/>
           <p:nvPr/>
         </p:nvSpPr>
         <p:spPr>
           <a:xfrm>
-            <a:off x="3474720" y="3803904"/>
-            <a:ext cx="5394960" cy="274320"/>
+            <a:off x="265176" y="4315968"/>
+            <a:ext cx="2377440" cy="274320"/>
           </a:xfrm>
           <a:prstGeom prst="rect">
             <a:avLst/>
@@ -10015,59 +10071,14 @@
               </a:lnSpc>
             </a:pPr>
             <a:r>
-              <a:rPr sz="1000" b="0">
-                <a:solidFill>
-                  <a:srgbClr val="1A73E8"/>
-                </a:solidFill>
-                <a:latin typeface="Arial"/>
-                <a:hlinkClick r:id="rId5"/>
-              </a:rPr>
-              <a:t>34-93-190-64.sslip.io/v1</a:t>
-            </a:r>
-          </a:p>
-        </p:txBody>
-      </p:sp>
-      <p:sp>
-        <p:nvSpPr>
-          <p:cNvPr id="15" name="Rectangle 14"/>
-          <p:cNvSpPr/>
-          <p:nvPr/>
-        </p:nvSpPr>
-        <p:spPr>
-          <a:xfrm>
-            <a:off x="265176" y="4526280"/>
-            <a:ext cx="8613648" cy="10972"/>
-          </a:xfrm>
-          <a:prstGeom prst="rect">
-            <a:avLst/>
-          </a:prstGeom>
-          <a:solidFill>
-            <a:srgbClr val="DADCE0"/>
-          </a:solidFill>
-          <a:ln>
-            <a:noFill/>
-          </a:ln>
-          <a:effectLst/>
-        </p:spPr>
-        <p:style>
-          <a:lnRef idx="1">
-            <a:schemeClr val="accent1"/>
-          </a:lnRef>
-          <a:fillRef idx="3">
-            <a:schemeClr val="accent1"/>
-          </a:fillRef>
-          <a:effectRef idx="2">
-            <a:schemeClr val="accent1"/>
-          </a:effectRef>
-          <a:fontRef idx="minor">
-            <a:schemeClr val="lt1"/>
-          </a:fontRef>
-        </p:style>
-        <p:txBody>
-          <a:bodyPr rtlCol="0" anchor="ctr"/>
-          <a:lstStyle/>
-          <a:p>
-            <a:pPr algn="l"/>
+              <a:rPr sz="1050" b="1">
+                <a:solidFill>
+                  <a:srgbClr val="202124"/>
+                </a:solidFill>
+                <a:latin typeface="Arial"/>
+              </a:rPr>
+              <a:t>Live API</a:t>
+            </a:r>
           </a:p>
         </p:txBody>
       </p:sp>
@@ -10079,8 +10090,8 @@
         </p:nvSpPr>
         <p:spPr>
           <a:xfrm>
-            <a:off x="265176" y="4617720"/>
-            <a:ext cx="8613648" cy="274320"/>
+            <a:off x="2697480" y="4315968"/>
+            <a:ext cx="6126480" cy="274320"/>
           </a:xfrm>
           <a:prstGeom prst="rect">
             <a:avLst/>
@@ -10099,13 +10110,14 @@
               </a:lnSpc>
             </a:pPr>
             <a:r>
-              <a:rPr sz="800" b="0">
-                <a:solidFill>
-                  <a:srgbClr val="9AA0A6"/>
-                </a:solidFill>
-                <a:latin typeface="Arial"/>
-              </a:rPr>
-              <a:t>The dashboard opens with no credential in the URL; sign in with the project token once (Settings → sign in).</a:t>
+              <a:rPr sz="1000" b="0">
+                <a:solidFill>
+                  <a:srgbClr val="1A73E8"/>
+                </a:solidFill>
+                <a:latin typeface="Arial"/>
+                <a:hlinkClick r:id="rId5"/>
+              </a:rPr>
+              <a:t>34-93-190-64.sslip.io/v1</a:t>
             </a:r>
           </a:p>
         </p:txBody>

</xml_diff>

<commit_message>
t_deckv3-links docs: team leader, full product link, no video placeholder (#277)
Slide 1: team leader name is Florentiana Yuwono.

Slide 16: the demo-video row is gone. The final product link is now the full
dashboard URL with apiBase, projectId, synthetic=1 and dest=fleet, split across
two lines so it stays readable at 8 pt, with both lines carrying the hyperlink.

The demo token is printed on the slide rather than appended to the URL: the
dashboard refuses a ?token= parameter by design (dashboard/config.js, task
t_5649d117) and scrubs it from the address bar, so a tokenised link would drop
the viewer at the sign-in prompt with the credential stripped.

Co-authored-by: Termini Agent <agent@termini.local>
</commit_message>
<xml_diff>
--- a/deck/v3/termini-deck-v3.pptx
+++ b/deck/v3/termini-deck-v3.pptx
@@ -5581,7 +5581,7 @@
                 </a:solidFill>
                 <a:latin typeface="Arial"/>
               </a:rPr>
-              <a:t>[to be filled]</a:t>
+              <a:t>Florentiana Yuwono</a:t>
             </a:r>
           </a:p>
           <a:p>
@@ -9720,8 +9720,8 @@
         </p:nvSpPr>
         <p:spPr>
           <a:xfrm>
-            <a:off x="265176" y="1828800"/>
-            <a:ext cx="3108960" cy="274320"/>
+            <a:off x="265176" y="1783080"/>
+            <a:ext cx="2377440" cy="274320"/>
           </a:xfrm>
           <a:prstGeom prst="rect">
             <a:avLst/>
@@ -9759,8 +9759,8 @@
         </p:nvSpPr>
         <p:spPr>
           <a:xfrm>
-            <a:off x="3474720" y="1828800"/>
-            <a:ext cx="5394960" cy="274320"/>
+            <a:off x="2697480" y="1783080"/>
+            <a:ext cx="6126480" cy="274320"/>
           </a:xfrm>
           <a:prstGeom prst="rect">
             <a:avLst/>
@@ -9799,8 +9799,8 @@
         </p:nvSpPr>
         <p:spPr>
           <a:xfrm>
-            <a:off x="265176" y="2487168"/>
-            <a:ext cx="3108960" cy="274320"/>
+            <a:off x="265176" y="2286000"/>
+            <a:ext cx="2377440" cy="274320"/>
           </a:xfrm>
           <a:prstGeom prst="rect">
             <a:avLst/>
@@ -9825,7 +9825,7 @@
                 </a:solidFill>
                 <a:latin typeface="Arial"/>
               </a:rPr>
-              <a:t>Demo video (3 minutes)</a:t>
+              <a:t>Final product link</a:t>
             </a:r>
           </a:p>
         </p:txBody>
@@ -9838,8 +9838,8 @@
         </p:nvSpPr>
         <p:spPr>
           <a:xfrm>
-            <a:off x="3474720" y="2487168"/>
-            <a:ext cx="5394960" cy="274320"/>
+            <a:off x="265176" y="2578608"/>
+            <a:ext cx="8613648" cy="228600"/>
           </a:xfrm>
           <a:prstGeom prst="rect">
             <a:avLst/>
@@ -9858,13 +9858,13 @@
               </a:lnSpc>
             </a:pPr>
             <a:r>
-              <a:rPr sz="1000" b="0">
-                <a:solidFill>
-                  <a:srgbClr val="B06000"/>
-                </a:solidFill>
-                <a:latin typeface="Arial"/>
-              </a:rPr>
-              <a:t>script ready; recording is the pending human step (SUBMISSION.md §5)</a:t>
+              <a:rPr sz="800" b="0">
+                <a:solidFill>
+                  <a:srgbClr val="5F6368"/>
+                </a:solidFill>
+                <a:latin typeface="Arial"/>
+              </a:rPr>
+              <a:t>opens the full dashboard: fleet, operator log, agents panel, synthetic nodes included</a:t>
             </a:r>
           </a:p>
         </p:txBody>
@@ -9877,8 +9877,65 @@
         </p:nvSpPr>
         <p:spPr>
           <a:xfrm>
-            <a:off x="265176" y="3145536"/>
-            <a:ext cx="3108960" cy="274320"/>
+            <a:off x="2697480" y="2852928"/>
+            <a:ext cx="6126480" cy="502920"/>
+          </a:xfrm>
+          <a:prstGeom prst="rect">
+            <a:avLst/>
+          </a:prstGeom>
+          <a:noFill/>
+        </p:spPr>
+        <p:txBody>
+          <a:bodyPr wrap="square" lIns="0" rIns="0" tIns="0" bIns="0" anchor="t">
+            <a:spAutoFit/>
+          </a:bodyPr>
+          <a:lstStyle/>
+          <a:p>
+            <a:pPr algn="l">
+              <a:lnSpc>
+                <a:spcPct val="135000"/>
+              </a:lnSpc>
+            </a:pPr>
+            <a:r>
+              <a:rPr sz="800" b="0">
+                <a:solidFill>
+                  <a:srgbClr val="1A73E8"/>
+                </a:solidFill>
+                <a:latin typeface="Arial"/>
+                <a:hlinkClick r:id="rId4"/>
+              </a:rPr>
+              <a:t>https://termini-510609.web.app/?apiBase=https%3A%2F%2F34-93-190-64.sslip.io%2Fv1</a:t>
+            </a:r>
+          </a:p>
+          <a:p>
+            <a:pPr algn="l">
+              <a:lnSpc>
+                <a:spcPct val="135000"/>
+              </a:lnSpc>
+            </a:pPr>
+            <a:r>
+              <a:rPr sz="800" b="0">
+                <a:solidFill>
+                  <a:srgbClr val="1A73E8"/>
+                </a:solidFill>
+                <a:latin typeface="Arial"/>
+                <a:hlinkClick r:id="rId4"/>
+              </a:rPr>
+              <a:t>&amp;projectId=01J0DEM0WARM000000000000AB&amp;synthetic=1&amp;dest=fleet</a:t>
+            </a:r>
+          </a:p>
+        </p:txBody>
+      </p:sp>
+      <p:sp>
+        <p:nvSpPr>
+          <p:cNvPr id="12" name="TextBox 11"/>
+          <p:cNvSpPr txBox="1"/>
+          <p:nvPr/>
+        </p:nvSpPr>
+        <p:spPr>
+          <a:xfrm>
+            <a:off x="265176" y="3611880"/>
+            <a:ext cx="2377440" cy="274320"/>
           </a:xfrm>
           <a:prstGeom prst="rect">
             <a:avLst/>
@@ -9903,21 +9960,21 @@
                 </a:solidFill>
                 <a:latin typeface="Arial"/>
               </a:rPr>
-              <a:t>Final product link</a:t>
-            </a:r>
-          </a:p>
-        </p:txBody>
-      </p:sp>
-      <p:sp>
-        <p:nvSpPr>
-          <p:cNvPr id="12" name="TextBox 11"/>
+              <a:t>Demo sign-in</a:t>
+            </a:r>
+          </a:p>
+        </p:txBody>
+      </p:sp>
+      <p:sp>
+        <p:nvSpPr>
+          <p:cNvPr id="13" name="TextBox 12"/>
           <p:cNvSpPr txBox="1"/>
           <p:nvPr/>
         </p:nvSpPr>
         <p:spPr>
           <a:xfrm>
-            <a:off x="3474720" y="3145536"/>
-            <a:ext cx="5394960" cy="274320"/>
+            <a:off x="2697480" y="3611880"/>
+            <a:ext cx="6126480" cy="274320"/>
           </a:xfrm>
           <a:prstGeom prst="rect">
             <a:avLst/>
@@ -9938,26 +9995,25 @@
             <a:r>
               <a:rPr sz="1000" b="0">
                 <a:solidFill>
-                  <a:srgbClr val="1A73E8"/>
-                </a:solidFill>
-                <a:latin typeface="Arial"/>
-                <a:hlinkClick r:id="rId4"/>
-              </a:rPr>
-              <a:t>termini-510609.web.app</a:t>
-            </a:r>
-          </a:p>
-        </p:txBody>
-      </p:sp>
-      <p:sp>
-        <p:nvSpPr>
-          <p:cNvPr id="13" name="TextBox 12"/>
+                  <a:srgbClr val="202124"/>
+                </a:solidFill>
+                <a:latin typeface="Arial"/>
+              </a:rPr>
+              <a:t>project token: demo-project-token</a:t>
+            </a:r>
+          </a:p>
+        </p:txBody>
+      </p:sp>
+      <p:sp>
+        <p:nvSpPr>
+          <p:cNvPr id="14" name="TextBox 13"/>
           <p:cNvSpPr txBox="1"/>
           <p:nvPr/>
         </p:nvSpPr>
         <p:spPr>
           <a:xfrm>
-            <a:off x="265176" y="3803904"/>
-            <a:ext cx="3108960" cy="274320"/>
+            <a:off x="2697480" y="3877056"/>
+            <a:ext cx="6126480" cy="274320"/>
           </a:xfrm>
           <a:prstGeom prst="rect">
             <a:avLst/>
@@ -9976,27 +10032,27 @@
               </a:lnSpc>
             </a:pPr>
             <a:r>
-              <a:rPr sz="1050" b="1">
-                <a:solidFill>
-                  <a:srgbClr val="202124"/>
-                </a:solidFill>
-                <a:latin typeface="Arial"/>
-              </a:rPr>
-              <a:t>Live API</a:t>
-            </a:r>
-          </a:p>
-        </p:txBody>
-      </p:sp>
-      <p:sp>
-        <p:nvSpPr>
-          <p:cNvPr id="14" name="TextBox 13"/>
+              <a:rPr sz="800" b="0">
+                <a:solidFill>
+                  <a:srgbClr val="5F6368"/>
+                </a:solidFill>
+                <a:latin typeface="Arial"/>
+              </a:rPr>
+              <a:t>the dashboard refuses a token inside a URL, so the token is printed here; paste it at Settings, then sign in</a:t>
+            </a:r>
+          </a:p>
+        </p:txBody>
+      </p:sp>
+      <p:sp>
+        <p:nvSpPr>
+          <p:cNvPr id="15" name="TextBox 14"/>
           <p:cNvSpPr txBox="1"/>
           <p:nvPr/>
         </p:nvSpPr>
         <p:spPr>
           <a:xfrm>
-            <a:off x="3474720" y="3803904"/>
-            <a:ext cx="5394960" cy="274320"/>
+            <a:off x="265176" y="4315968"/>
+            <a:ext cx="2377440" cy="274320"/>
           </a:xfrm>
           <a:prstGeom prst="rect">
             <a:avLst/>
@@ -10015,59 +10071,14 @@
               </a:lnSpc>
             </a:pPr>
             <a:r>
-              <a:rPr sz="1000" b="0">
-                <a:solidFill>
-                  <a:srgbClr val="1A73E8"/>
-                </a:solidFill>
-                <a:latin typeface="Arial"/>
-                <a:hlinkClick r:id="rId5"/>
-              </a:rPr>
-              <a:t>34-93-190-64.sslip.io/v1</a:t>
-            </a:r>
-          </a:p>
-        </p:txBody>
-      </p:sp>
-      <p:sp>
-        <p:nvSpPr>
-          <p:cNvPr id="15" name="Rectangle 14"/>
-          <p:cNvSpPr/>
-          <p:nvPr/>
-        </p:nvSpPr>
-        <p:spPr>
-          <a:xfrm>
-            <a:off x="265176" y="4526280"/>
-            <a:ext cx="8613648" cy="10972"/>
-          </a:xfrm>
-          <a:prstGeom prst="rect">
-            <a:avLst/>
-          </a:prstGeom>
-          <a:solidFill>
-            <a:srgbClr val="DADCE0"/>
-          </a:solidFill>
-          <a:ln>
-            <a:noFill/>
-          </a:ln>
-          <a:effectLst/>
-        </p:spPr>
-        <p:style>
-          <a:lnRef idx="1">
-            <a:schemeClr val="accent1"/>
-          </a:lnRef>
-          <a:fillRef idx="3">
-            <a:schemeClr val="accent1"/>
-          </a:fillRef>
-          <a:effectRef idx="2">
-            <a:schemeClr val="accent1"/>
-          </a:effectRef>
-          <a:fontRef idx="minor">
-            <a:schemeClr val="lt1"/>
-          </a:fontRef>
-        </p:style>
-        <p:txBody>
-          <a:bodyPr rtlCol="0" anchor="ctr"/>
-          <a:lstStyle/>
-          <a:p>
-            <a:pPr algn="l"/>
+              <a:rPr sz="1050" b="1">
+                <a:solidFill>
+                  <a:srgbClr val="202124"/>
+                </a:solidFill>
+                <a:latin typeface="Arial"/>
+              </a:rPr>
+              <a:t>Live API</a:t>
+            </a:r>
           </a:p>
         </p:txBody>
       </p:sp>
@@ -10079,8 +10090,8 @@
         </p:nvSpPr>
         <p:spPr>
           <a:xfrm>
-            <a:off x="265176" y="4617720"/>
-            <a:ext cx="8613648" cy="274320"/>
+            <a:off x="2697480" y="4315968"/>
+            <a:ext cx="6126480" cy="274320"/>
           </a:xfrm>
           <a:prstGeom prst="rect">
             <a:avLst/>
@@ -10099,13 +10110,14 @@
               </a:lnSpc>
             </a:pPr>
             <a:r>
-              <a:rPr sz="800" b="0">
-                <a:solidFill>
-                  <a:srgbClr val="9AA0A6"/>
-                </a:solidFill>
-                <a:latin typeface="Arial"/>
-              </a:rPr>
-              <a:t>The dashboard opens with no credential in the URL; sign in with the project token once (Settings → sign in).</a:t>
+              <a:rPr sz="1000" b="0">
+                <a:solidFill>
+                  <a:srgbClr val="1A73E8"/>
+                </a:solidFill>
+                <a:latin typeface="Arial"/>
+                <a:hlinkClick r:id="rId5"/>
+              </a:rPr>
+              <a:t>34-93-190-64.sslip.io/v1</a:t>
             </a:r>
           </a:p>
         </p:txBody>

</xml_diff>